<commit_message>
Update Kreiner Burns proposal: Full Service Marketing Starter only, standalone price ($5,697/mo)
Removed Elite Coach Plus. Updated package to standalone pricing. Adjusted slide 3 layout for single-package display.

Co-Authored-By: Claude Sonnet 4.6 <noreply@anthropic.com>
</commit_message>
<xml_diff>
--- a/kreiner-burns/KreinerBurns_June11_2026_Proposal.pptx
+++ b/kreiner-burns/KreinerBurns_June11_2026_Proposal.pptx
@@ -5670,33 +5670,9 @@
           </a:p>
         </p:txBody>
       </p:sp>
-      <p:pic>
-        <p:nvPicPr>
-          <p:cNvPr id="70" name="Picture 69" descr="smb_team_logo.png"/>
-          <p:cNvPicPr>
-            <a:picLocks noChangeAspect="1"/>
-          </p:cNvPicPr>
-          <p:nvPr/>
-        </p:nvPicPr>
-        <p:blipFill>
-          <a:blip r:embed="rId2"/>
-          <a:stretch>
-            <a:fillRect/>
-          </a:stretch>
-        </p:blipFill>
-        <p:spPr>
-          <a:xfrm>
-            <a:off x="201168" y="4837176"/>
-            <a:ext cx="1170432" cy="237744"/>
-          </a:xfrm>
-          <a:prstGeom prst="rect">
-            <a:avLst/>
-          </a:prstGeom>
-        </p:spPr>
-      </p:pic>
-      <p:sp>
-        <p:nvSpPr>
-          <p:cNvPr id="71" name="TextBox 70"/>
+      <p:sp>
+        <p:nvSpPr>
+          <p:cNvPr id="70" name="TextBox 69"/>
           <p:cNvSpPr txBox="1"/>
           <p:nvPr/>
         </p:nvSpPr>
@@ -5729,7 +5705,7 @@
       </p:sp>
       <p:sp>
         <p:nvSpPr>
-          <p:cNvPr id="72" name="TextBox 71"/>
+          <p:cNvPr id="71" name="TextBox 70"/>
           <p:cNvSpPr txBox="1"/>
           <p:nvPr/>
         </p:nvSpPr>
@@ -8478,33 +8454,9 @@
           </a:p>
         </p:txBody>
       </p:sp>
-      <p:pic>
-        <p:nvPicPr>
-          <p:cNvPr id="70" name="Picture 69" descr="smb_team_logo.png"/>
-          <p:cNvPicPr>
-            <a:picLocks noChangeAspect="1"/>
-          </p:cNvPicPr>
-          <p:nvPr/>
-        </p:nvPicPr>
-        <p:blipFill>
-          <a:blip r:embed="rId2"/>
-          <a:stretch>
-            <a:fillRect/>
-          </a:stretch>
-        </p:blipFill>
-        <p:spPr>
-          <a:xfrm>
-            <a:off x="201168" y="4837176"/>
-            <a:ext cx="1170432" cy="237744"/>
-          </a:xfrm>
-          <a:prstGeom prst="rect">
-            <a:avLst/>
-          </a:prstGeom>
-        </p:spPr>
-      </p:pic>
-      <p:sp>
-        <p:nvSpPr>
-          <p:cNvPr id="71" name="TextBox 70"/>
+      <p:sp>
+        <p:nvSpPr>
+          <p:cNvPr id="70" name="TextBox 69"/>
           <p:cNvSpPr txBox="1"/>
           <p:nvPr/>
         </p:nvSpPr>
@@ -8537,7 +8489,7 @@
       </p:sp>
       <p:sp>
         <p:nvSpPr>
-          <p:cNvPr id="72" name="TextBox 71"/>
+          <p:cNvPr id="71" name="TextBox 70"/>
           <p:cNvSpPr txBox="1"/>
           <p:nvPr/>
         </p:nvSpPr>
@@ -8848,7 +8800,7 @@
                 </a:solidFill>
                 <a:latin typeface="Calibri"/>
               </a:rPr>
-              <a:t>$4,847</a:t>
+              <a:t>$5,697</a:t>
             </a:r>
           </a:p>
         </p:txBody>
@@ -8894,84 +8846,6 @@
         </p:nvSpPr>
         <p:spPr>
           <a:xfrm>
-            <a:off x="2322576" y="1426464"/>
-            <a:ext cx="914400" cy="237744"/>
-          </a:xfrm>
-          <a:prstGeom prst="rect">
-            <a:avLst/>
-          </a:prstGeom>
-          <a:noFill/>
-        </p:spPr>
-        <p:txBody>
-          <a:bodyPr wrap="square"/>
-          <a:lstStyle/>
-          <a:p>
-            <a:pPr algn="l"/>
-            <a:r>
-              <a:rPr sz="1100" b="0" i="0">
-                <a:solidFill>
-                  <a:srgbClr val="334155"/>
-                </a:solidFill>
-                <a:latin typeface="Calibri"/>
-              </a:rPr>
-              <a:t>$5,697/mo</a:t>
-            </a:r>
-          </a:p>
-        </p:txBody>
-      </p:sp>
-      <p:sp>
-        <p:nvSpPr>
-          <p:cNvPr id="11" name="Rectangle 10"/>
-          <p:cNvSpPr/>
-          <p:nvPr/>
-        </p:nvSpPr>
-        <p:spPr>
-          <a:xfrm>
-            <a:off x="2322576" y="1527048"/>
-            <a:ext cx="804672" cy="9144"/>
-          </a:xfrm>
-          <a:prstGeom prst="rect">
-            <a:avLst/>
-          </a:prstGeom>
-          <a:solidFill>
-            <a:srgbClr val="334155"/>
-          </a:solidFill>
-          <a:ln>
-            <a:solidFill>
-              <a:srgbClr val="FFFFFF"/>
-            </a:solidFill>
-          </a:ln>
-        </p:spPr>
-        <p:style>
-          <a:lnRef idx="1">
-            <a:schemeClr val="accent1"/>
-          </a:lnRef>
-          <a:fillRef idx="3">
-            <a:schemeClr val="accent1"/>
-          </a:fillRef>
-          <a:effectRef idx="2">
-            <a:schemeClr val="accent1"/>
-          </a:effectRef>
-          <a:fontRef idx="minor">
-            <a:schemeClr val="lt1"/>
-          </a:fontRef>
-        </p:style>
-        <p:txBody>
-          <a:bodyPr rtlCol="0" anchor="ctr"/>
-          <a:lstStyle/>
-          <a:p>
-            <a:pPr algn="ctr"/>
-          </a:p>
-        </p:txBody>
-      </p:sp>
-      <p:sp>
-        <p:nvSpPr>
-          <p:cNvPr id="12" name="TextBox 11"/>
-          <p:cNvSpPr txBox="1"/>
-          <p:nvPr/>
-        </p:nvSpPr>
-        <p:spPr>
-          <a:xfrm>
             <a:off x="475488" y="1792224"/>
             <a:ext cx="3803904" cy="201168"/>
           </a:xfrm>
@@ -8999,313 +8873,13 @@
       </p:sp>
       <p:sp>
         <p:nvSpPr>
-          <p:cNvPr id="13" name="Rectangle 12"/>
+          <p:cNvPr id="11" name="Rectangle 10"/>
           <p:cNvSpPr/>
           <p:nvPr/>
         </p:nvSpPr>
         <p:spPr>
           <a:xfrm>
-            <a:off x="201168" y="2139696"/>
-            <a:ext cx="4133087" cy="1024128"/>
-          </a:xfrm>
-          <a:prstGeom prst="rect">
-            <a:avLst/>
-          </a:prstGeom>
-          <a:solidFill>
-            <a:srgbClr val="FFFFFF"/>
-          </a:solidFill>
-          <a:ln>
-            <a:solidFill>
-              <a:srgbClr val="FFFFFF"/>
-            </a:solidFill>
-          </a:ln>
-        </p:spPr>
-        <p:style>
-          <a:lnRef idx="1">
-            <a:schemeClr val="accent1"/>
-          </a:lnRef>
-          <a:fillRef idx="3">
-            <a:schemeClr val="accent1"/>
-          </a:fillRef>
-          <a:effectRef idx="2">
-            <a:schemeClr val="accent1"/>
-          </a:effectRef>
-          <a:fontRef idx="minor">
-            <a:schemeClr val="lt1"/>
-          </a:fontRef>
-        </p:style>
-        <p:txBody>
-          <a:bodyPr rtlCol="0" anchor="ctr"/>
-          <a:lstStyle/>
-          <a:p>
-            <a:pPr algn="ctr"/>
-          </a:p>
-        </p:txBody>
-      </p:sp>
-      <p:sp>
-        <p:nvSpPr>
-          <p:cNvPr id="14" name="Rectangle 13"/>
-          <p:cNvSpPr/>
-          <p:nvPr/>
-        </p:nvSpPr>
-        <p:spPr>
-          <a:xfrm>
-            <a:off x="201168" y="2139696"/>
-            <a:ext cx="182880" cy="1024128"/>
-          </a:xfrm>
-          <a:prstGeom prst="rect">
-            <a:avLst/>
-          </a:prstGeom>
-          <a:solidFill>
-            <a:srgbClr val="6D28D9"/>
-          </a:solidFill>
-          <a:ln>
-            <a:solidFill>
-              <a:srgbClr val="FFFFFF"/>
-            </a:solidFill>
-          </a:ln>
-        </p:spPr>
-        <p:style>
-          <a:lnRef idx="1">
-            <a:schemeClr val="accent1"/>
-          </a:lnRef>
-          <a:fillRef idx="3">
-            <a:schemeClr val="accent1"/>
-          </a:fillRef>
-          <a:effectRef idx="2">
-            <a:schemeClr val="accent1"/>
-          </a:effectRef>
-          <a:fontRef idx="minor">
-            <a:schemeClr val="lt1"/>
-          </a:fontRef>
-        </p:style>
-        <p:txBody>
-          <a:bodyPr rtlCol="0" anchor="ctr"/>
-          <a:lstStyle/>
-          <a:p>
-            <a:pPr algn="ctr"/>
-          </a:p>
-        </p:txBody>
-      </p:sp>
-      <p:sp>
-        <p:nvSpPr>
-          <p:cNvPr id="15" name="TextBox 14"/>
-          <p:cNvSpPr txBox="1"/>
-          <p:nvPr/>
-        </p:nvSpPr>
-        <p:spPr>
-          <a:xfrm>
-            <a:off x="475488" y="2231136"/>
-            <a:ext cx="3803904" cy="201168"/>
-          </a:xfrm>
-          <a:prstGeom prst="rect">
-            <a:avLst/>
-          </a:prstGeom>
-          <a:noFill/>
-        </p:spPr>
-        <p:txBody>
-          <a:bodyPr wrap="square"/>
-          <a:lstStyle/>
-          <a:p>
-            <a:pPr algn="l"/>
-            <a:r>
-              <a:rPr sz="800" b="1" i="0">
-                <a:solidFill>
-                  <a:srgbClr val="6D28D9"/>
-                </a:solidFill>
-                <a:latin typeface="Calibri"/>
-              </a:rPr>
-              <a:t>ELITE COACH PLUS</a:t>
-            </a:r>
-          </a:p>
-        </p:txBody>
-      </p:sp>
-      <p:sp>
-        <p:nvSpPr>
-          <p:cNvPr id="16" name="TextBox 15"/>
-          <p:cNvSpPr txBox="1"/>
-          <p:nvPr/>
-        </p:nvSpPr>
-        <p:spPr>
-          <a:xfrm>
-            <a:off x="475488" y="2414015"/>
-            <a:ext cx="1828800" cy="438912"/>
-          </a:xfrm>
-          <a:prstGeom prst="rect">
-            <a:avLst/>
-          </a:prstGeom>
-          <a:noFill/>
-        </p:spPr>
-        <p:txBody>
-          <a:bodyPr wrap="square"/>
-          <a:lstStyle/>
-          <a:p>
-            <a:pPr algn="l"/>
-            <a:r>
-              <a:rPr sz="3200" b="1" i="0">
-                <a:solidFill>
-                  <a:srgbClr val="0D1F3C"/>
-                </a:solidFill>
-                <a:latin typeface="Calibri"/>
-              </a:rPr>
-              <a:t>$3,200</a:t>
-            </a:r>
-          </a:p>
-        </p:txBody>
-      </p:sp>
-      <p:sp>
-        <p:nvSpPr>
-          <p:cNvPr id="17" name="TextBox 16"/>
-          <p:cNvSpPr txBox="1"/>
-          <p:nvPr/>
-        </p:nvSpPr>
-        <p:spPr>
-          <a:xfrm>
-            <a:off x="1865376" y="2523744"/>
-            <a:ext cx="420624" cy="256032"/>
-          </a:xfrm>
-          <a:prstGeom prst="rect">
-            <a:avLst/>
-          </a:prstGeom>
-          <a:noFill/>
-        </p:spPr>
-        <p:txBody>
-          <a:bodyPr wrap="square"/>
-          <a:lstStyle/>
-          <a:p>
-            <a:pPr algn="l"/>
-            <a:r>
-              <a:rPr sz="1100" b="0" i="0">
-                <a:solidFill>
-                  <a:srgbClr val="64748B"/>
-                </a:solidFill>
-                <a:latin typeface="Calibri"/>
-              </a:rPr>
-              <a:t>/mo</a:t>
-            </a:r>
-          </a:p>
-        </p:txBody>
-      </p:sp>
-      <p:sp>
-        <p:nvSpPr>
-          <p:cNvPr id="18" name="TextBox 17"/>
-          <p:cNvSpPr txBox="1"/>
-          <p:nvPr/>
-        </p:nvSpPr>
-        <p:spPr>
-          <a:xfrm>
-            <a:off x="2322576" y="2542032"/>
-            <a:ext cx="914400" cy="237744"/>
-          </a:xfrm>
-          <a:prstGeom prst="rect">
-            <a:avLst/>
-          </a:prstGeom>
-          <a:noFill/>
-        </p:spPr>
-        <p:txBody>
-          <a:bodyPr wrap="square"/>
-          <a:lstStyle/>
-          <a:p>
-            <a:pPr algn="l"/>
-            <a:r>
-              <a:rPr sz="1100" b="0" i="0">
-                <a:solidFill>
-                  <a:srgbClr val="334155"/>
-                </a:solidFill>
-                <a:latin typeface="Calibri"/>
-              </a:rPr>
-              <a:t>$3,497/mo</a:t>
-            </a:r>
-          </a:p>
-        </p:txBody>
-      </p:sp>
-      <p:sp>
-        <p:nvSpPr>
-          <p:cNvPr id="19" name="Rectangle 18"/>
-          <p:cNvSpPr/>
-          <p:nvPr/>
-        </p:nvSpPr>
-        <p:spPr>
-          <a:xfrm>
-            <a:off x="2322576" y="2642615"/>
-            <a:ext cx="804672" cy="9144"/>
-          </a:xfrm>
-          <a:prstGeom prst="rect">
-            <a:avLst/>
-          </a:prstGeom>
-          <a:solidFill>
-            <a:srgbClr val="334155"/>
-          </a:solidFill>
-          <a:ln>
-            <a:solidFill>
-              <a:srgbClr val="FFFFFF"/>
-            </a:solidFill>
-          </a:ln>
-        </p:spPr>
-        <p:style>
-          <a:lnRef idx="1">
-            <a:schemeClr val="accent1"/>
-          </a:lnRef>
-          <a:fillRef idx="3">
-            <a:schemeClr val="accent1"/>
-          </a:fillRef>
-          <a:effectRef idx="2">
-            <a:schemeClr val="accent1"/>
-          </a:effectRef>
-          <a:fontRef idx="minor">
-            <a:schemeClr val="lt1"/>
-          </a:fontRef>
-        </p:style>
-        <p:txBody>
-          <a:bodyPr rtlCol="0" anchor="ctr"/>
-          <a:lstStyle/>
-          <a:p>
-            <a:pPr algn="ctr"/>
-          </a:p>
-        </p:txBody>
-      </p:sp>
-      <p:sp>
-        <p:nvSpPr>
-          <p:cNvPr id="20" name="TextBox 19"/>
-          <p:cNvSpPr txBox="1"/>
-          <p:nvPr/>
-        </p:nvSpPr>
-        <p:spPr>
-          <a:xfrm>
-            <a:off x="475488" y="2907791"/>
-            <a:ext cx="3803904" cy="201168"/>
-          </a:xfrm>
-          <a:prstGeom prst="rect">
-            <a:avLst/>
-          </a:prstGeom>
-          <a:noFill/>
-        </p:spPr>
-        <p:txBody>
-          <a:bodyPr wrap="square"/>
-          <a:lstStyle/>
-          <a:p>
-            <a:pPr algn="l"/>
-            <a:r>
-              <a:rPr sz="800" b="0" i="0">
-                <a:solidFill>
-                  <a:srgbClr val="64748B"/>
-                </a:solidFill>
-                <a:latin typeface="Calibri"/>
-              </a:rPr>
-              <a:t>Weekly coaching · Intake protocol · Revenue roadmap</a:t>
-            </a:r>
-          </a:p>
-        </p:txBody>
-      </p:sp>
-      <p:sp>
-        <p:nvSpPr>
-          <p:cNvPr id="21" name="Rectangle 20"/>
-          <p:cNvSpPr/>
-          <p:nvPr/>
-        </p:nvSpPr>
-        <p:spPr>
-          <a:xfrm>
-            <a:off x="201168" y="3255264"/>
+            <a:off x="201168" y="2176272"/>
             <a:ext cx="4133087" cy="658368"/>
           </a:xfrm>
           <a:prstGeom prst="rect">
@@ -9344,13 +8918,13 @@
       </p:sp>
       <p:sp>
         <p:nvSpPr>
-          <p:cNvPr id="22" name="TextBox 21"/>
+          <p:cNvPr id="12" name="TextBox 11"/>
           <p:cNvSpPr txBox="1"/>
           <p:nvPr/>
         </p:nvSpPr>
         <p:spPr>
           <a:xfrm>
-            <a:off x="384048" y="3291840"/>
+            <a:off x="384048" y="2212848"/>
             <a:ext cx="1645920" cy="237744"/>
           </a:xfrm>
           <a:prstGeom prst="rect">
@@ -9370,20 +8944,20 @@
                 </a:solidFill>
                 <a:latin typeface="Calibri"/>
               </a:rPr>
-              <a:t>BUNDLE TOTAL</a:t>
-            </a:r>
-          </a:p>
-        </p:txBody>
-      </p:sp>
-      <p:sp>
-        <p:nvSpPr>
-          <p:cNvPr id="23" name="TextBox 22"/>
+              <a:t>TOTAL</a:t>
+            </a:r>
+          </a:p>
+        </p:txBody>
+      </p:sp>
+      <p:sp>
+        <p:nvSpPr>
+          <p:cNvPr id="13" name="TextBox 12"/>
           <p:cNvSpPr txBox="1"/>
           <p:nvPr/>
         </p:nvSpPr>
         <p:spPr>
           <a:xfrm>
-            <a:off x="384048" y="3493008"/>
+            <a:off x="384048" y="2414015"/>
             <a:ext cx="2194560" cy="347472"/>
           </a:xfrm>
           <a:prstGeom prst="rect">
@@ -9403,20 +8977,20 @@
                 </a:solidFill>
                 <a:latin typeface="Calibri"/>
               </a:rPr>
-              <a:t>$8,047 / mo</a:t>
-            </a:r>
-          </a:p>
-        </p:txBody>
-      </p:sp>
-      <p:sp>
-        <p:nvSpPr>
-          <p:cNvPr id="24" name="TextBox 23"/>
+              <a:t>$5,697 / mo</a:t>
+            </a:r>
+          </a:p>
+        </p:txBody>
+      </p:sp>
+      <p:sp>
+        <p:nvSpPr>
+          <p:cNvPr id="14" name="TextBox 13"/>
           <p:cNvSpPr txBox="1"/>
           <p:nvPr/>
         </p:nvSpPr>
         <p:spPr>
           <a:xfrm>
-            <a:off x="2670048" y="3493008"/>
+            <a:off x="2670048" y="2414015"/>
             <a:ext cx="1737360" cy="347472"/>
           </a:xfrm>
           <a:prstGeom prst="rect">
@@ -9436,20 +9010,20 @@
                 </a:solidFill>
                 <a:latin typeface="Calibri"/>
               </a:rPr>
-              <a:t>Save $1,147/mo by bundling</a:t>
-            </a:r>
-          </a:p>
-        </p:txBody>
-      </p:sp>
-      <p:sp>
-        <p:nvSpPr>
-          <p:cNvPr id="25" name="Rectangle 24"/>
+              <a:t>Standalone pricing</a:t>
+            </a:r>
+          </a:p>
+        </p:txBody>
+      </p:sp>
+      <p:sp>
+        <p:nvSpPr>
+          <p:cNvPr id="15" name="Rectangle 14"/>
           <p:cNvSpPr/>
           <p:nvPr/>
         </p:nvSpPr>
         <p:spPr>
           <a:xfrm>
-            <a:off x="201168" y="3968496"/>
+            <a:off x="201168" y="2889504"/>
             <a:ext cx="4133087" cy="402336"/>
           </a:xfrm>
           <a:prstGeom prst="rect">
@@ -9488,13 +9062,13 @@
       </p:sp>
       <p:sp>
         <p:nvSpPr>
-          <p:cNvPr id="26" name="TextBox 25"/>
+          <p:cNvPr id="16" name="TextBox 15"/>
           <p:cNvSpPr txBox="1"/>
           <p:nvPr/>
         </p:nvSpPr>
         <p:spPr>
           <a:xfrm>
-            <a:off x="329184" y="3995928"/>
+            <a:off x="329184" y="2916936"/>
             <a:ext cx="3931920" cy="347472"/>
           </a:xfrm>
           <a:prstGeom prst="rect">
@@ -9521,7 +9095,7 @@
       </p:sp>
       <p:sp>
         <p:nvSpPr>
-          <p:cNvPr id="27" name="Rectangle 26"/>
+          <p:cNvPr id="17" name="Rectangle 16"/>
           <p:cNvSpPr/>
           <p:nvPr/>
         </p:nvSpPr>
@@ -9566,7 +9140,7 @@
       </p:sp>
       <p:sp>
         <p:nvSpPr>
-          <p:cNvPr id="28" name="TextBox 27"/>
+          <p:cNvPr id="18" name="TextBox 17"/>
           <p:cNvSpPr txBox="1"/>
           <p:nvPr/>
         </p:nvSpPr>
@@ -9599,7 +9173,7 @@
       </p:sp>
       <p:sp>
         <p:nvSpPr>
-          <p:cNvPr id="29" name="TextBox 28"/>
+          <p:cNvPr id="19" name="TextBox 18"/>
           <p:cNvSpPr txBox="1"/>
           <p:nvPr/>
         </p:nvSpPr>
@@ -9632,7 +9206,7 @@
       </p:sp>
       <p:sp>
         <p:nvSpPr>
-          <p:cNvPr id="30" name="TextBox 29"/>
+          <p:cNvPr id="20" name="TextBox 19"/>
           <p:cNvSpPr txBox="1"/>
           <p:nvPr/>
         </p:nvSpPr>
@@ -9665,7 +9239,7 @@
       </p:sp>
       <p:sp>
         <p:nvSpPr>
-          <p:cNvPr id="31" name="Rectangle 30"/>
+          <p:cNvPr id="21" name="Rectangle 20"/>
           <p:cNvSpPr/>
           <p:nvPr/>
         </p:nvSpPr>
@@ -9710,7 +9284,7 @@
       </p:sp>
       <p:sp>
         <p:nvSpPr>
-          <p:cNvPr id="32" name="TextBox 31"/>
+          <p:cNvPr id="22" name="TextBox 21"/>
           <p:cNvSpPr txBox="1"/>
           <p:nvPr/>
         </p:nvSpPr>
@@ -9743,7 +9317,7 @@
       </p:sp>
       <p:sp>
         <p:nvSpPr>
-          <p:cNvPr id="33" name="TextBox 32"/>
+          <p:cNvPr id="23" name="TextBox 22"/>
           <p:cNvSpPr txBox="1"/>
           <p:nvPr/>
         </p:nvSpPr>
@@ -9776,7 +9350,7 @@
       </p:sp>
       <p:sp>
         <p:nvSpPr>
-          <p:cNvPr id="34" name="TextBox 33"/>
+          <p:cNvPr id="24" name="TextBox 23"/>
           <p:cNvSpPr txBox="1"/>
           <p:nvPr/>
         </p:nvSpPr>
@@ -9809,7 +9383,7 @@
       </p:sp>
       <p:sp>
         <p:nvSpPr>
-          <p:cNvPr id="35" name="TextBox 34"/>
+          <p:cNvPr id="25" name="TextBox 24"/>
           <p:cNvSpPr txBox="1"/>
           <p:nvPr/>
         </p:nvSpPr>
@@ -9842,7 +9416,7 @@
       </p:sp>
       <p:sp>
         <p:nvSpPr>
-          <p:cNvPr id="36" name="TextBox 35"/>
+          <p:cNvPr id="26" name="TextBox 25"/>
           <p:cNvSpPr txBox="1"/>
           <p:nvPr/>
         </p:nvSpPr>
@@ -9875,7 +9449,7 @@
       </p:sp>
       <p:sp>
         <p:nvSpPr>
-          <p:cNvPr id="37" name="Rectangle 36"/>
+          <p:cNvPr id="27" name="Rectangle 26"/>
           <p:cNvSpPr/>
           <p:nvPr/>
         </p:nvSpPr>
@@ -9920,7 +9494,7 @@
       </p:sp>
       <p:sp>
         <p:nvSpPr>
-          <p:cNvPr id="38" name="TextBox 37"/>
+          <p:cNvPr id="28" name="TextBox 27"/>
           <p:cNvSpPr txBox="1"/>
           <p:nvPr/>
         </p:nvSpPr>
@@ -9953,7 +9527,7 @@
       </p:sp>
       <p:sp>
         <p:nvSpPr>
-          <p:cNvPr id="39" name="TextBox 38"/>
+          <p:cNvPr id="29" name="TextBox 28"/>
           <p:cNvSpPr txBox="1"/>
           <p:nvPr/>
         </p:nvSpPr>
@@ -9986,7 +9560,7 @@
       </p:sp>
       <p:sp>
         <p:nvSpPr>
-          <p:cNvPr id="40" name="Rectangle 39"/>
+          <p:cNvPr id="30" name="Rectangle 29"/>
           <p:cNvSpPr/>
           <p:nvPr/>
         </p:nvSpPr>
@@ -10031,7 +9605,7 @@
       </p:sp>
       <p:sp>
         <p:nvSpPr>
-          <p:cNvPr id="41" name="TextBox 40"/>
+          <p:cNvPr id="31" name="TextBox 30"/>
           <p:cNvSpPr txBox="1"/>
           <p:nvPr/>
         </p:nvSpPr>
@@ -10064,7 +9638,7 @@
       </p:sp>
       <p:sp>
         <p:nvSpPr>
-          <p:cNvPr id="42" name="TextBox 41"/>
+          <p:cNvPr id="32" name="TextBox 31"/>
           <p:cNvSpPr txBox="1"/>
           <p:nvPr/>
         </p:nvSpPr>
@@ -10097,7 +9671,7 @@
       </p:sp>
       <p:sp>
         <p:nvSpPr>
-          <p:cNvPr id="43" name="Rectangle 42"/>
+          <p:cNvPr id="33" name="Rectangle 32"/>
           <p:cNvSpPr/>
           <p:nvPr/>
         </p:nvSpPr>
@@ -10142,7 +9716,7 @@
       </p:sp>
       <p:sp>
         <p:nvSpPr>
-          <p:cNvPr id="44" name="TextBox 43"/>
+          <p:cNvPr id="34" name="TextBox 33"/>
           <p:cNvSpPr txBox="1"/>
           <p:nvPr/>
         </p:nvSpPr>
@@ -10175,7 +9749,7 @@
       </p:sp>
       <p:sp>
         <p:nvSpPr>
-          <p:cNvPr id="45" name="TextBox 44"/>
+          <p:cNvPr id="35" name="TextBox 34"/>
           <p:cNvSpPr txBox="1"/>
           <p:nvPr/>
         </p:nvSpPr>
@@ -10208,7 +9782,7 @@
       </p:sp>
       <p:sp>
         <p:nvSpPr>
-          <p:cNvPr id="46" name="Rectangle 45"/>
+          <p:cNvPr id="36" name="Rectangle 35"/>
           <p:cNvSpPr/>
           <p:nvPr/>
         </p:nvSpPr>
@@ -10253,7 +9827,7 @@
       </p:sp>
       <p:sp>
         <p:nvSpPr>
-          <p:cNvPr id="47" name="TextBox 46"/>
+          <p:cNvPr id="37" name="TextBox 36"/>
           <p:cNvSpPr txBox="1"/>
           <p:nvPr/>
         </p:nvSpPr>
@@ -10286,7 +9860,7 @@
       </p:sp>
       <p:sp>
         <p:nvSpPr>
-          <p:cNvPr id="48" name="TextBox 47"/>
+          <p:cNvPr id="38" name="TextBox 37"/>
           <p:cNvSpPr txBox="1"/>
           <p:nvPr/>
         </p:nvSpPr>
@@ -10319,7 +9893,7 @@
       </p:sp>
       <p:sp>
         <p:nvSpPr>
-          <p:cNvPr id="49" name="Rectangle 48"/>
+          <p:cNvPr id="39" name="Rectangle 38"/>
           <p:cNvSpPr/>
           <p:nvPr/>
         </p:nvSpPr>
@@ -10364,7 +9938,7 @@
       </p:sp>
       <p:sp>
         <p:nvSpPr>
-          <p:cNvPr id="50" name="TextBox 49"/>
+          <p:cNvPr id="40" name="TextBox 39"/>
           <p:cNvSpPr txBox="1"/>
           <p:nvPr/>
         </p:nvSpPr>
@@ -10397,7 +9971,7 @@
       </p:sp>
       <p:sp>
         <p:nvSpPr>
-          <p:cNvPr id="51" name="TextBox 50"/>
+          <p:cNvPr id="41" name="TextBox 40"/>
           <p:cNvSpPr txBox="1"/>
           <p:nvPr/>
         </p:nvSpPr>
@@ -10430,7 +10004,7 @@
       </p:sp>
       <p:sp>
         <p:nvSpPr>
-          <p:cNvPr id="52" name="Rectangle 51"/>
+          <p:cNvPr id="42" name="Rectangle 41"/>
           <p:cNvSpPr/>
           <p:nvPr/>
         </p:nvSpPr>
@@ -10475,7 +10049,7 @@
       </p:sp>
       <p:sp>
         <p:nvSpPr>
-          <p:cNvPr id="53" name="TextBox 52"/>
+          <p:cNvPr id="43" name="TextBox 42"/>
           <p:cNvSpPr txBox="1"/>
           <p:nvPr/>
         </p:nvSpPr>
@@ -10508,7 +10082,7 @@
       </p:sp>
       <p:sp>
         <p:nvSpPr>
-          <p:cNvPr id="54" name="Rectangle 53"/>
+          <p:cNvPr id="44" name="Rectangle 43"/>
           <p:cNvSpPr/>
           <p:nvPr/>
         </p:nvSpPr>
@@ -10551,33 +10125,9 @@
           </a:p>
         </p:txBody>
       </p:sp>
-      <p:pic>
-        <p:nvPicPr>
-          <p:cNvPr id="55" name="Picture 54" descr="smb_team_logo.png"/>
-          <p:cNvPicPr>
-            <a:picLocks noChangeAspect="1"/>
-          </p:cNvPicPr>
-          <p:nvPr/>
-        </p:nvPicPr>
-        <p:blipFill>
-          <a:blip r:embed="rId2"/>
-          <a:stretch>
-            <a:fillRect/>
-          </a:stretch>
-        </p:blipFill>
-        <p:spPr>
-          <a:xfrm>
-            <a:off x="201168" y="4837176"/>
-            <a:ext cx="1170432" cy="237744"/>
-          </a:xfrm>
-          <a:prstGeom prst="rect">
-            <a:avLst/>
-          </a:prstGeom>
-        </p:spPr>
-      </p:pic>
-      <p:sp>
-        <p:nvSpPr>
-          <p:cNvPr id="56" name="TextBox 55"/>
+      <p:sp>
+        <p:nvSpPr>
+          <p:cNvPr id="45" name="TextBox 44"/>
           <p:cNvSpPr txBox="1"/>
           <p:nvPr/>
         </p:nvSpPr>
@@ -10610,7 +10160,7 @@
       </p:sp>
       <p:sp>
         <p:nvSpPr>
-          <p:cNvPr id="57" name="TextBox 56"/>
+          <p:cNvPr id="46" name="TextBox 45"/>
           <p:cNvSpPr txBox="1"/>
           <p:nvPr/>
         </p:nvSpPr>

</xml_diff>